<commit_message>
Presi ist top Jonas danke <3
</commit_message>
<xml_diff>
--- a/Litter Detection.pptx
+++ b/Litter Detection.pptx
@@ -1262,7 +1262,7 @@
           <a:noFill/>
           <a:extLst>
             <a:ext uri="{909E8E84-426E-40dd-AFC4-6F175D3DCCD1}">
-              <a14:hiddenFill xmlns="" xmlns:a14="http://schemas.microsoft.com/office/drawing/2010/main">
+              <a14:hiddenFill xmlns:a14="http://schemas.microsoft.com/office/drawing/2010/main" xmlns="">
                 <a:solidFill>
                   <a:srgbClr val="FFFFFF"/>
                 </a:solidFill>
@@ -1321,7 +1321,7 @@
             </a:ln>
             <a:extLst>
               <a:ext uri="{91240B29-F687-4f45-9708-019B960494DF}">
-                <a14:hiddenLine xmlns="" xmlns:a14="http://schemas.microsoft.com/office/drawing/2010/main" w="9525">
+                <a14:hiddenLine xmlns:a14="http://schemas.microsoft.com/office/drawing/2010/main" xmlns="" w="9525">
                   <a:solidFill>
                     <a:srgbClr val="000000"/>
                   </a:solidFill>
@@ -1418,7 +1418,7 @@
             </a:ln>
             <a:extLst>
               <a:ext uri="{91240B29-F687-4f45-9708-019B960494DF}">
-                <a14:hiddenLine xmlns="" xmlns:a14="http://schemas.microsoft.com/office/drawing/2010/main" w="9525">
+                <a14:hiddenLine xmlns:a14="http://schemas.microsoft.com/office/drawing/2010/main" xmlns="" w="9525">
                   <a:solidFill>
                     <a:srgbClr val="000000"/>
                   </a:solidFill>
@@ -1515,7 +1515,7 @@
             </a:ln>
             <a:extLst>
               <a:ext uri="{91240B29-F687-4f45-9708-019B960494DF}">
-                <a14:hiddenLine xmlns="" xmlns:a14="http://schemas.microsoft.com/office/drawing/2010/main" w="9525">
+                <a14:hiddenLine xmlns:a14="http://schemas.microsoft.com/office/drawing/2010/main" xmlns="" w="9525">
                   <a:solidFill>
                     <a:srgbClr val="000000"/>
                   </a:solidFill>
@@ -1556,7 +1556,7 @@
             </a:ln>
             <a:extLst>
               <a:ext uri="{91240B29-F687-4f45-9708-019B960494DF}">
-                <a14:hiddenLine xmlns="" xmlns:a14="http://schemas.microsoft.com/office/drawing/2010/main" w="9525">
+                <a14:hiddenLine xmlns:a14="http://schemas.microsoft.com/office/drawing/2010/main" xmlns="" w="9525">
                   <a:solidFill>
                     <a:srgbClr val="000000"/>
                   </a:solidFill>
@@ -1653,7 +1653,7 @@
             </a:ln>
             <a:extLst>
               <a:ext uri="{91240B29-F687-4f45-9708-019B960494DF}">
-                <a14:hiddenLine xmlns="" xmlns:a14="http://schemas.microsoft.com/office/drawing/2010/main" w="9525">
+                <a14:hiddenLine xmlns:a14="http://schemas.microsoft.com/office/drawing/2010/main" xmlns="" w="9525">
                   <a:solidFill>
                     <a:srgbClr val="000000"/>
                   </a:solidFill>
@@ -1722,7 +1722,7 @@
             </a:ln>
             <a:extLst>
               <a:ext uri="{91240B29-F687-4f45-9708-019B960494DF}">
-                <a14:hiddenLine xmlns="" xmlns:a14="http://schemas.microsoft.com/office/drawing/2010/main" w="9525">
+                <a14:hiddenLine xmlns:a14="http://schemas.microsoft.com/office/drawing/2010/main" xmlns="" w="9525">
                   <a:solidFill>
                     <a:srgbClr val="000000"/>
                   </a:solidFill>
@@ -1791,7 +1791,7 @@
             </a:ln>
             <a:extLst>
               <a:ext uri="{91240B29-F687-4f45-9708-019B960494DF}">
-                <a14:hiddenLine xmlns="" xmlns:a14="http://schemas.microsoft.com/office/drawing/2010/main" w="9525">
+                <a14:hiddenLine xmlns:a14="http://schemas.microsoft.com/office/drawing/2010/main" xmlns="" w="9525">
                   <a:solidFill>
                     <a:srgbClr val="000000"/>
                   </a:solidFill>
@@ -1888,7 +1888,7 @@
             </a:ln>
             <a:extLst>
               <a:ext uri="{91240B29-F687-4f45-9708-019B960494DF}">
-                <a14:hiddenLine xmlns="" xmlns:a14="http://schemas.microsoft.com/office/drawing/2010/main" w="9525">
+                <a14:hiddenLine xmlns:a14="http://schemas.microsoft.com/office/drawing/2010/main" xmlns="" w="9525">
                   <a:solidFill>
                     <a:srgbClr val="000000"/>
                   </a:solidFill>
@@ -1957,7 +1957,7 @@
             </a:ln>
             <a:extLst>
               <a:ext uri="{91240B29-F687-4f45-9708-019B960494DF}">
-                <a14:hiddenLine xmlns="" xmlns:a14="http://schemas.microsoft.com/office/drawing/2010/main" w="9525">
+                <a14:hiddenLine xmlns:a14="http://schemas.microsoft.com/office/drawing/2010/main" xmlns="" w="9525">
                   <a:solidFill>
                     <a:srgbClr val="000000"/>
                   </a:solidFill>
@@ -2026,7 +2026,7 @@
             </a:ln>
             <a:extLst>
               <a:ext uri="{91240B29-F687-4f45-9708-019B960494DF}">
-                <a14:hiddenLine xmlns="" xmlns:a14="http://schemas.microsoft.com/office/drawing/2010/main" w="9525">
+                <a14:hiddenLine xmlns:a14="http://schemas.microsoft.com/office/drawing/2010/main" xmlns="" w="9525">
                   <a:solidFill>
                     <a:srgbClr val="000000"/>
                   </a:solidFill>
@@ -2123,7 +2123,7 @@
             </a:ln>
             <a:extLst>
               <a:ext uri="{91240B29-F687-4f45-9708-019B960494DF}">
-                <a14:hiddenLine xmlns="" xmlns:a14="http://schemas.microsoft.com/office/drawing/2010/main" w="9525">
+                <a14:hiddenLine xmlns:a14="http://schemas.microsoft.com/office/drawing/2010/main" xmlns="" w="9525">
                   <a:solidFill>
                     <a:srgbClr val="000000"/>
                   </a:solidFill>
@@ -2220,7 +2220,7 @@
             </a:ln>
             <a:extLst>
               <a:ext uri="{91240B29-F687-4f45-9708-019B960494DF}">
-                <a14:hiddenLine xmlns="" xmlns:a14="http://schemas.microsoft.com/office/drawing/2010/main" w="9525">
+                <a14:hiddenLine xmlns:a14="http://schemas.microsoft.com/office/drawing/2010/main" xmlns="" w="9525">
                   <a:solidFill>
                     <a:srgbClr val="000000"/>
                   </a:solidFill>
@@ -2289,7 +2289,7 @@
             </a:ln>
             <a:extLst>
               <a:ext uri="{91240B29-F687-4f45-9708-019B960494DF}">
-                <a14:hiddenLine xmlns="" xmlns:a14="http://schemas.microsoft.com/office/drawing/2010/main" w="9525">
+                <a14:hiddenLine xmlns:a14="http://schemas.microsoft.com/office/drawing/2010/main" xmlns="" w="9525">
                   <a:solidFill>
                     <a:srgbClr val="000000"/>
                   </a:solidFill>
@@ -2406,7 +2406,7 @@
             </a:ln>
             <a:extLst>
               <a:ext uri="{91240B29-F687-4f45-9708-019B960494DF}">
-                <a14:hiddenLine xmlns="" xmlns:a14="http://schemas.microsoft.com/office/drawing/2010/main" w="9525">
+                <a14:hiddenLine xmlns:a14="http://schemas.microsoft.com/office/drawing/2010/main" xmlns="" w="9525">
                   <a:solidFill>
                     <a:srgbClr val="000000"/>
                   </a:solidFill>
@@ -2475,7 +2475,7 @@
             </a:ln>
             <a:extLst>
               <a:ext uri="{91240B29-F687-4f45-9708-019B960494DF}">
-                <a14:hiddenLine xmlns="" xmlns:a14="http://schemas.microsoft.com/office/drawing/2010/main" w="9525">
+                <a14:hiddenLine xmlns:a14="http://schemas.microsoft.com/office/drawing/2010/main" xmlns="" w="9525">
                   <a:solidFill>
                     <a:srgbClr val="000000"/>
                   </a:solidFill>
@@ -2572,7 +2572,7 @@
             </a:ln>
             <a:extLst>
               <a:ext uri="{91240B29-F687-4f45-9708-019B960494DF}">
-                <a14:hiddenLine xmlns="" xmlns:a14="http://schemas.microsoft.com/office/drawing/2010/main" w="9525">
+                <a14:hiddenLine xmlns:a14="http://schemas.microsoft.com/office/drawing/2010/main" xmlns="" w="9525">
                   <a:solidFill>
                     <a:srgbClr val="000000"/>
                   </a:solidFill>
@@ -2669,7 +2669,7 @@
             </a:ln>
             <a:extLst>
               <a:ext uri="{91240B29-F687-4f45-9708-019B960494DF}">
-                <a14:hiddenLine xmlns="" xmlns:a14="http://schemas.microsoft.com/office/drawing/2010/main" w="9525">
+                <a14:hiddenLine xmlns:a14="http://schemas.microsoft.com/office/drawing/2010/main" xmlns="" w="9525">
                   <a:solidFill>
                     <a:srgbClr val="000000"/>
                   </a:solidFill>
@@ -2738,7 +2738,7 @@
             </a:ln>
             <a:extLst>
               <a:ext uri="{91240B29-F687-4f45-9708-019B960494DF}">
-                <a14:hiddenLine xmlns="" xmlns:a14="http://schemas.microsoft.com/office/drawing/2010/main" w="9525">
+                <a14:hiddenLine xmlns:a14="http://schemas.microsoft.com/office/drawing/2010/main" xmlns="" w="9525">
                   <a:solidFill>
                     <a:srgbClr val="000000"/>
                   </a:solidFill>
@@ -2835,7 +2835,7 @@
             </a:ln>
             <a:extLst>
               <a:ext uri="{91240B29-F687-4f45-9708-019B960494DF}">
-                <a14:hiddenLine xmlns="" xmlns:a14="http://schemas.microsoft.com/office/drawing/2010/main" w="9525">
+                <a14:hiddenLine xmlns:a14="http://schemas.microsoft.com/office/drawing/2010/main" xmlns="" w="9525">
                   <a:solidFill>
                     <a:srgbClr val="000000"/>
                   </a:solidFill>
@@ -2932,7 +2932,7 @@
             </a:ln>
             <a:extLst>
               <a:ext uri="{91240B29-F687-4f45-9708-019B960494DF}">
-                <a14:hiddenLine xmlns="" xmlns:a14="http://schemas.microsoft.com/office/drawing/2010/main" w="9525">
+                <a14:hiddenLine xmlns:a14="http://schemas.microsoft.com/office/drawing/2010/main" xmlns="" w="9525">
                   <a:solidFill>
                     <a:srgbClr val="000000"/>
                   </a:solidFill>
@@ -2995,7 +2995,7 @@
             </a:ln>
             <a:extLst>
               <a:ext uri="{91240B29-F687-4f45-9708-019B960494DF}">
-                <a14:hiddenLine xmlns="" xmlns:a14="http://schemas.microsoft.com/office/drawing/2010/main" w="9525">
+                <a14:hiddenLine xmlns:a14="http://schemas.microsoft.com/office/drawing/2010/main" xmlns="" w="9525">
                   <a:solidFill>
                     <a:srgbClr val="000000"/>
                   </a:solidFill>
@@ -3092,7 +3092,7 @@
             </a:ln>
             <a:extLst>
               <a:ext uri="{91240B29-F687-4f45-9708-019B960494DF}">
-                <a14:hiddenLine xmlns="" xmlns:a14="http://schemas.microsoft.com/office/drawing/2010/main" w="9525">
+                <a14:hiddenLine xmlns:a14="http://schemas.microsoft.com/office/drawing/2010/main" xmlns="" w="9525">
                   <a:solidFill>
                     <a:srgbClr val="000000"/>
                   </a:solidFill>
@@ -3155,7 +3155,7 @@
             </a:ln>
             <a:extLst>
               <a:ext uri="{91240B29-F687-4f45-9708-019B960494DF}">
-                <a14:hiddenLine xmlns="" xmlns:a14="http://schemas.microsoft.com/office/drawing/2010/main" w="9525">
+                <a14:hiddenLine xmlns:a14="http://schemas.microsoft.com/office/drawing/2010/main" xmlns="" w="9525">
                   <a:solidFill>
                     <a:srgbClr val="000000"/>
                   </a:solidFill>
@@ -3252,7 +3252,7 @@
             </a:ln>
             <a:extLst>
               <a:ext uri="{91240B29-F687-4f45-9708-019B960494DF}">
-                <a14:hiddenLine xmlns="" xmlns:a14="http://schemas.microsoft.com/office/drawing/2010/main" w="9525">
+                <a14:hiddenLine xmlns:a14="http://schemas.microsoft.com/office/drawing/2010/main" xmlns="" w="9525">
                   <a:solidFill>
                     <a:srgbClr val="000000"/>
                   </a:solidFill>
@@ -3327,7 +3327,7 @@
             </a:ln>
             <a:extLst>
               <a:ext uri="{91240B29-F687-4f45-9708-019B960494DF}">
-                <a14:hiddenLine xmlns="" xmlns:a14="http://schemas.microsoft.com/office/drawing/2010/main" w="9525">
+                <a14:hiddenLine xmlns:a14="http://schemas.microsoft.com/office/drawing/2010/main" xmlns="" w="9525">
                   <a:solidFill>
                     <a:srgbClr val="000000"/>
                   </a:solidFill>
@@ -3424,7 +3424,7 @@
             </a:ln>
             <a:extLst>
               <a:ext uri="{91240B29-F687-4f45-9708-019B960494DF}">
-                <a14:hiddenLine xmlns="" xmlns:a14="http://schemas.microsoft.com/office/drawing/2010/main" w="9525">
+                <a14:hiddenLine xmlns:a14="http://schemas.microsoft.com/office/drawing/2010/main" xmlns="" w="9525">
                   <a:solidFill>
                     <a:srgbClr val="000000"/>
                   </a:solidFill>
@@ -3499,7 +3499,7 @@
             </a:ln>
             <a:extLst>
               <a:ext uri="{91240B29-F687-4f45-9708-019B960494DF}">
-                <a14:hiddenLine xmlns="" xmlns:a14="http://schemas.microsoft.com/office/drawing/2010/main" w="9525">
+                <a14:hiddenLine xmlns:a14="http://schemas.microsoft.com/office/drawing/2010/main" xmlns="" w="9525">
                   <a:solidFill>
                     <a:srgbClr val="000000"/>
                   </a:solidFill>
@@ -3596,7 +3596,7 @@
             </a:ln>
             <a:extLst>
               <a:ext uri="{91240B29-F687-4f45-9708-019B960494DF}">
-                <a14:hiddenLine xmlns="" xmlns:a14="http://schemas.microsoft.com/office/drawing/2010/main" w="9525">
+                <a14:hiddenLine xmlns:a14="http://schemas.microsoft.com/office/drawing/2010/main" xmlns="" w="9525">
                   <a:solidFill>
                     <a:srgbClr val="000000"/>
                   </a:solidFill>
@@ -3637,7 +3637,7 @@
             </a:ln>
             <a:extLst>
               <a:ext uri="{91240B29-F687-4f45-9708-019B960494DF}">
-                <a14:hiddenLine xmlns="" xmlns:a14="http://schemas.microsoft.com/office/drawing/2010/main" w="9525">
+                <a14:hiddenLine xmlns:a14="http://schemas.microsoft.com/office/drawing/2010/main" xmlns="" w="9525">
                   <a:solidFill>
                     <a:srgbClr val="000000"/>
                   </a:solidFill>
@@ -3734,7 +3734,7 @@
             </a:ln>
             <a:extLst>
               <a:ext uri="{91240B29-F687-4f45-9708-019B960494DF}">
-                <a14:hiddenLine xmlns="" xmlns:a14="http://schemas.microsoft.com/office/drawing/2010/main" w="9525">
+                <a14:hiddenLine xmlns:a14="http://schemas.microsoft.com/office/drawing/2010/main" xmlns="" w="9525">
                   <a:solidFill>
                     <a:srgbClr val="000000"/>
                   </a:solidFill>
@@ -3803,7 +3803,7 @@
             </a:ln>
             <a:extLst>
               <a:ext uri="{91240B29-F687-4f45-9708-019B960494DF}">
-                <a14:hiddenLine xmlns="" xmlns:a14="http://schemas.microsoft.com/office/drawing/2010/main" w="9525">
+                <a14:hiddenLine xmlns:a14="http://schemas.microsoft.com/office/drawing/2010/main" xmlns="" w="9525">
                   <a:solidFill>
                     <a:srgbClr val="000000"/>
                   </a:solidFill>
@@ -3872,7 +3872,7 @@
             </a:ln>
             <a:extLst>
               <a:ext uri="{91240B29-F687-4f45-9708-019B960494DF}">
-                <a14:hiddenLine xmlns="" xmlns:a14="http://schemas.microsoft.com/office/drawing/2010/main" w="9525">
+                <a14:hiddenLine xmlns:a14="http://schemas.microsoft.com/office/drawing/2010/main" xmlns="" w="9525">
                   <a:solidFill>
                     <a:srgbClr val="000000"/>
                   </a:solidFill>
@@ -3969,7 +3969,7 @@
             </a:ln>
             <a:extLst>
               <a:ext uri="{91240B29-F687-4f45-9708-019B960494DF}">
-                <a14:hiddenLine xmlns="" xmlns:a14="http://schemas.microsoft.com/office/drawing/2010/main" w="9525">
+                <a14:hiddenLine xmlns:a14="http://schemas.microsoft.com/office/drawing/2010/main" xmlns="" w="9525">
                   <a:solidFill>
                     <a:srgbClr val="000000"/>
                   </a:solidFill>
@@ -4044,7 +4044,7 @@
             </a:ln>
             <a:extLst>
               <a:ext uri="{91240B29-F687-4f45-9708-019B960494DF}">
-                <a14:hiddenLine xmlns="" xmlns:a14="http://schemas.microsoft.com/office/drawing/2010/main" w="9525">
+                <a14:hiddenLine xmlns:a14="http://schemas.microsoft.com/office/drawing/2010/main" xmlns="" w="9525">
                   <a:solidFill>
                     <a:srgbClr val="000000"/>
                   </a:solidFill>
@@ -4113,7 +4113,7 @@
             </a:ln>
             <a:extLst>
               <a:ext uri="{91240B29-F687-4f45-9708-019B960494DF}">
-                <a14:hiddenLine xmlns="" xmlns:a14="http://schemas.microsoft.com/office/drawing/2010/main" w="9525">
+                <a14:hiddenLine xmlns:a14="http://schemas.microsoft.com/office/drawing/2010/main" xmlns="" w="9525">
                   <a:solidFill>
                     <a:srgbClr val="000000"/>
                   </a:solidFill>
@@ -4210,7 +4210,7 @@
             </a:ln>
             <a:extLst>
               <a:ext uri="{91240B29-F687-4f45-9708-019B960494DF}">
-                <a14:hiddenLine xmlns="" xmlns:a14="http://schemas.microsoft.com/office/drawing/2010/main" w="9525">
+                <a14:hiddenLine xmlns:a14="http://schemas.microsoft.com/office/drawing/2010/main" xmlns="" w="9525">
                   <a:solidFill>
                     <a:srgbClr val="000000"/>
                   </a:solidFill>
@@ -4279,7 +4279,7 @@
             </a:ln>
             <a:extLst>
               <a:ext uri="{91240B29-F687-4f45-9708-019B960494DF}">
-                <a14:hiddenLine xmlns="" xmlns:a14="http://schemas.microsoft.com/office/drawing/2010/main" w="9525">
+                <a14:hiddenLine xmlns:a14="http://schemas.microsoft.com/office/drawing/2010/main" xmlns="" w="9525">
                   <a:solidFill>
                     <a:srgbClr val="000000"/>
                   </a:solidFill>
@@ -4376,7 +4376,7 @@
             </a:ln>
             <a:extLst>
               <a:ext uri="{91240B29-F687-4f45-9708-019B960494DF}">
-                <a14:hiddenLine xmlns="" xmlns:a14="http://schemas.microsoft.com/office/drawing/2010/main" w="9525">
+                <a14:hiddenLine xmlns:a14="http://schemas.microsoft.com/office/drawing/2010/main" xmlns="" w="9525">
                   <a:solidFill>
                     <a:srgbClr val="000000"/>
                   </a:solidFill>
@@ -4445,7 +4445,7 @@
             </a:ln>
             <a:extLst>
               <a:ext uri="{91240B29-F687-4f45-9708-019B960494DF}">
-                <a14:hiddenLine xmlns="" xmlns:a14="http://schemas.microsoft.com/office/drawing/2010/main" w="9525">
+                <a14:hiddenLine xmlns:a14="http://schemas.microsoft.com/office/drawing/2010/main" xmlns="" w="9525">
                   <a:solidFill>
                     <a:srgbClr val="000000"/>
                   </a:solidFill>
@@ -4542,7 +4542,7 @@
             </a:ln>
             <a:extLst>
               <a:ext uri="{91240B29-F687-4f45-9708-019B960494DF}">
-                <a14:hiddenLine xmlns="" xmlns:a14="http://schemas.microsoft.com/office/drawing/2010/main" w="9525">
+                <a14:hiddenLine xmlns:a14="http://schemas.microsoft.com/office/drawing/2010/main" xmlns="" w="9525">
                   <a:solidFill>
                     <a:srgbClr val="000000"/>
                   </a:solidFill>
@@ -4583,7 +4583,7 @@
             </a:ln>
             <a:extLst>
               <a:ext uri="{91240B29-F687-4f45-9708-019B960494DF}">
-                <a14:hiddenLine xmlns="" xmlns:a14="http://schemas.microsoft.com/office/drawing/2010/main" w="9525">
+                <a14:hiddenLine xmlns:a14="http://schemas.microsoft.com/office/drawing/2010/main" xmlns="" w="9525">
                   <a:solidFill>
                     <a:srgbClr val="000000"/>
                   </a:solidFill>
@@ -4655,7 +4655,7 @@
             </a:ln>
             <a:extLst>
               <a:ext uri="{91240B29-F687-4f45-9708-019B960494DF}">
-                <a14:hiddenLine xmlns="" xmlns:a14="http://schemas.microsoft.com/office/drawing/2010/main" w="9525">
+                <a14:hiddenLine xmlns:a14="http://schemas.microsoft.com/office/drawing/2010/main" xmlns="" w="9525">
                   <a:solidFill>
                     <a:srgbClr val="000000"/>
                   </a:solidFill>
@@ -4752,7 +4752,7 @@
             </a:ln>
             <a:extLst>
               <a:ext uri="{91240B29-F687-4f45-9708-019B960494DF}">
-                <a14:hiddenLine xmlns="" xmlns:a14="http://schemas.microsoft.com/office/drawing/2010/main" w="9525">
+                <a14:hiddenLine xmlns:a14="http://schemas.microsoft.com/office/drawing/2010/main" xmlns="" w="9525">
                   <a:solidFill>
                     <a:srgbClr val="000000"/>
                   </a:solidFill>
@@ -4821,7 +4821,7 @@
             </a:ln>
             <a:extLst>
               <a:ext uri="{91240B29-F687-4f45-9708-019B960494DF}">
-                <a14:hiddenLine xmlns="" xmlns:a14="http://schemas.microsoft.com/office/drawing/2010/main" w="9525">
+                <a14:hiddenLine xmlns:a14="http://schemas.microsoft.com/office/drawing/2010/main" xmlns="" w="9525">
                   <a:solidFill>
                     <a:srgbClr val="000000"/>
                   </a:solidFill>
@@ -4918,7 +4918,7 @@
             </a:ln>
             <a:extLst>
               <a:ext uri="{91240B29-F687-4f45-9708-019B960494DF}">
-                <a14:hiddenLine xmlns="" xmlns:a14="http://schemas.microsoft.com/office/drawing/2010/main" w="9525">
+                <a14:hiddenLine xmlns:a14="http://schemas.microsoft.com/office/drawing/2010/main" xmlns="" w="9525">
                   <a:solidFill>
                     <a:srgbClr val="000000"/>
                   </a:solidFill>
@@ -5015,7 +5015,7 @@
             </a:ln>
             <a:extLst>
               <a:ext uri="{91240B29-F687-4f45-9708-019B960494DF}">
-                <a14:hiddenLine xmlns="" xmlns:a14="http://schemas.microsoft.com/office/drawing/2010/main" w="9525">
+                <a14:hiddenLine xmlns:a14="http://schemas.microsoft.com/office/drawing/2010/main" xmlns="" w="9525">
                   <a:solidFill>
                     <a:srgbClr val="000000"/>
                   </a:solidFill>
@@ -5087,7 +5087,7 @@
             </a:ln>
             <a:extLst>
               <a:ext uri="{91240B29-F687-4f45-9708-019B960494DF}">
-                <a14:hiddenLine xmlns="" xmlns:a14="http://schemas.microsoft.com/office/drawing/2010/main" w="9525">
+                <a14:hiddenLine xmlns:a14="http://schemas.microsoft.com/office/drawing/2010/main" xmlns="" w="9525">
                   <a:solidFill>
                     <a:srgbClr val="000000"/>
                   </a:solidFill>
@@ -5156,7 +5156,7 @@
             </a:ln>
             <a:extLst>
               <a:ext uri="{91240B29-F687-4f45-9708-019B960494DF}">
-                <a14:hiddenLine xmlns="" xmlns:a14="http://schemas.microsoft.com/office/drawing/2010/main" w="9525">
+                <a14:hiddenLine xmlns:a14="http://schemas.microsoft.com/office/drawing/2010/main" xmlns="" w="9525">
                   <a:solidFill>
                     <a:srgbClr val="000000"/>
                   </a:solidFill>
@@ -5253,7 +5253,7 @@
             </a:ln>
             <a:extLst>
               <a:ext uri="{91240B29-F687-4f45-9708-019B960494DF}">
-                <a14:hiddenLine xmlns="" xmlns:a14="http://schemas.microsoft.com/office/drawing/2010/main" w="9525">
+                <a14:hiddenLine xmlns:a14="http://schemas.microsoft.com/office/drawing/2010/main" xmlns="" w="9525">
                   <a:solidFill>
                     <a:srgbClr val="000000"/>
                   </a:solidFill>
@@ -5350,7 +5350,7 @@
             </a:ln>
             <a:extLst>
               <a:ext uri="{91240B29-F687-4f45-9708-019B960494DF}">
-                <a14:hiddenLine xmlns="" xmlns:a14="http://schemas.microsoft.com/office/drawing/2010/main" w="9525">
+                <a14:hiddenLine xmlns:a14="http://schemas.microsoft.com/office/drawing/2010/main" xmlns="" w="9525">
                   <a:solidFill>
                     <a:srgbClr val="000000"/>
                   </a:solidFill>
@@ -5419,7 +5419,7 @@
             </a:ln>
             <a:extLst>
               <a:ext uri="{91240B29-F687-4f45-9708-019B960494DF}">
-                <a14:hiddenLine xmlns="" xmlns:a14="http://schemas.microsoft.com/office/drawing/2010/main" w="9525">
+                <a14:hiddenLine xmlns:a14="http://schemas.microsoft.com/office/drawing/2010/main" xmlns="" w="9525">
                   <a:solidFill>
                     <a:srgbClr val="000000"/>
                   </a:solidFill>
@@ -5546,7 +5546,7 @@
             </a:ln>
             <a:extLst>
               <a:ext uri="{91240B29-F687-4f45-9708-019B960494DF}">
-                <a14:hiddenLine xmlns="" xmlns:a14="http://schemas.microsoft.com/office/drawing/2010/main" w="9525">
+                <a14:hiddenLine xmlns:a14="http://schemas.microsoft.com/office/drawing/2010/main" xmlns="" w="9525">
                   <a:solidFill>
                     <a:srgbClr val="000000"/>
                   </a:solidFill>
@@ -5621,7 +5621,7 @@
             </a:ln>
             <a:extLst>
               <a:ext uri="{91240B29-F687-4f45-9708-019B960494DF}">
-                <a14:hiddenLine xmlns="" xmlns:a14="http://schemas.microsoft.com/office/drawing/2010/main" w="9525">
+                <a14:hiddenLine xmlns:a14="http://schemas.microsoft.com/office/drawing/2010/main" xmlns="" w="9525">
                   <a:solidFill>
                     <a:srgbClr val="000000"/>
                   </a:solidFill>
@@ -5718,7 +5718,7 @@
             </a:ln>
             <a:extLst>
               <a:ext uri="{91240B29-F687-4f45-9708-019B960494DF}">
-                <a14:hiddenLine xmlns="" xmlns:a14="http://schemas.microsoft.com/office/drawing/2010/main" w="9525">
+                <a14:hiddenLine xmlns:a14="http://schemas.microsoft.com/office/drawing/2010/main" xmlns="" w="9525">
                   <a:solidFill>
                     <a:srgbClr val="000000"/>
                   </a:solidFill>
@@ -10539,7 +10539,7 @@
           <a:noFill/>
           <a:extLst>
             <a:ext uri="{909E8E84-426E-40dd-AFC4-6F175D3DCCD1}">
-              <a14:hiddenFill xmlns="" xmlns:a14="http://schemas.microsoft.com/office/drawing/2010/main">
+              <a14:hiddenFill xmlns:a14="http://schemas.microsoft.com/office/drawing/2010/main" xmlns="">
                 <a:solidFill>
                   <a:srgbClr val="FFFFFF"/>
                 </a:solidFill>
@@ -10613,7 +10613,7 @@
               </a:ln>
               <a:extLst>
                 <a:ext uri="{91240B29-F687-4f45-9708-019B960494DF}">
-                  <a14:hiddenLine xmlns="" xmlns:a14="http://schemas.microsoft.com/office/drawing/2010/main" w="9525">
+                  <a14:hiddenLine xmlns:a14="http://schemas.microsoft.com/office/drawing/2010/main" xmlns="" w="9525">
                     <a:solidFill>
                       <a:srgbClr val="000000"/>
                     </a:solidFill>
@@ -10710,7 +10710,7 @@
               </a:ln>
               <a:extLst>
                 <a:ext uri="{91240B29-F687-4f45-9708-019B960494DF}">
-                  <a14:hiddenLine xmlns="" xmlns:a14="http://schemas.microsoft.com/office/drawing/2010/main" w="9525">
+                  <a14:hiddenLine xmlns:a14="http://schemas.microsoft.com/office/drawing/2010/main" xmlns="" w="9525">
                     <a:solidFill>
                       <a:srgbClr val="000000"/>
                     </a:solidFill>
@@ -10807,7 +10807,7 @@
               </a:ln>
               <a:extLst>
                 <a:ext uri="{91240B29-F687-4f45-9708-019B960494DF}">
-                  <a14:hiddenLine xmlns="" xmlns:a14="http://schemas.microsoft.com/office/drawing/2010/main" w="9525">
+                  <a14:hiddenLine xmlns:a14="http://schemas.microsoft.com/office/drawing/2010/main" xmlns="" w="9525">
                     <a:solidFill>
                       <a:srgbClr val="000000"/>
                     </a:solidFill>
@@ -10876,7 +10876,7 @@
               </a:ln>
               <a:extLst>
                 <a:ext uri="{91240B29-F687-4f45-9708-019B960494DF}">
-                  <a14:hiddenLine xmlns="" xmlns:a14="http://schemas.microsoft.com/office/drawing/2010/main" w="9525">
+                  <a14:hiddenLine xmlns:a14="http://schemas.microsoft.com/office/drawing/2010/main" xmlns="" w="9525">
                     <a:solidFill>
                       <a:srgbClr val="000000"/>
                     </a:solidFill>
@@ -10973,7 +10973,7 @@
               </a:ln>
               <a:extLst>
                 <a:ext uri="{91240B29-F687-4f45-9708-019B960494DF}">
-                  <a14:hiddenLine xmlns="" xmlns:a14="http://schemas.microsoft.com/office/drawing/2010/main" w="9525">
+                  <a14:hiddenLine xmlns:a14="http://schemas.microsoft.com/office/drawing/2010/main" xmlns="" w="9525">
                     <a:solidFill>
                       <a:srgbClr val="000000"/>
                     </a:solidFill>
@@ -11042,7 +11042,7 @@
               </a:ln>
               <a:extLst>
                 <a:ext uri="{91240B29-F687-4f45-9708-019B960494DF}">
-                  <a14:hiddenLine xmlns="" xmlns:a14="http://schemas.microsoft.com/office/drawing/2010/main" w="9525">
+                  <a14:hiddenLine xmlns:a14="http://schemas.microsoft.com/office/drawing/2010/main" xmlns="" w="9525">
                     <a:solidFill>
                       <a:srgbClr val="000000"/>
                     </a:solidFill>
@@ -11111,7 +11111,7 @@
               </a:ln>
               <a:extLst>
                 <a:ext uri="{91240B29-F687-4f45-9708-019B960494DF}">
-                  <a14:hiddenLine xmlns="" xmlns:a14="http://schemas.microsoft.com/office/drawing/2010/main" w="9525">
+                  <a14:hiddenLine xmlns:a14="http://schemas.microsoft.com/office/drawing/2010/main" xmlns="" w="9525">
                     <a:solidFill>
                       <a:srgbClr val="000000"/>
                     </a:solidFill>
@@ -11208,7 +11208,7 @@
               </a:ln>
               <a:extLst>
                 <a:ext uri="{91240B29-F687-4f45-9708-019B960494DF}">
-                  <a14:hiddenLine xmlns="" xmlns:a14="http://schemas.microsoft.com/office/drawing/2010/main" w="9525">
+                  <a14:hiddenLine xmlns:a14="http://schemas.microsoft.com/office/drawing/2010/main" xmlns="" w="9525">
                     <a:solidFill>
                       <a:srgbClr val="000000"/>
                     </a:solidFill>
@@ -11305,7 +11305,7 @@
               </a:ln>
               <a:extLst>
                 <a:ext uri="{91240B29-F687-4f45-9708-019B960494DF}">
-                  <a14:hiddenLine xmlns="" xmlns:a14="http://schemas.microsoft.com/office/drawing/2010/main" w="9525">
+                  <a14:hiddenLine xmlns:a14="http://schemas.microsoft.com/office/drawing/2010/main" xmlns="" w="9525">
                     <a:solidFill>
                       <a:srgbClr val="000000"/>
                     </a:solidFill>
@@ -11374,7 +11374,7 @@
               </a:ln>
               <a:extLst>
                 <a:ext uri="{91240B29-F687-4f45-9708-019B960494DF}">
-                  <a14:hiddenLine xmlns="" xmlns:a14="http://schemas.microsoft.com/office/drawing/2010/main" w="9525">
+                  <a14:hiddenLine xmlns:a14="http://schemas.microsoft.com/office/drawing/2010/main" xmlns="" w="9525">
                     <a:solidFill>
                       <a:srgbClr val="000000"/>
                     </a:solidFill>
@@ -11491,7 +11491,7 @@
               </a:ln>
               <a:extLst>
                 <a:ext uri="{91240B29-F687-4f45-9708-019B960494DF}">
-                  <a14:hiddenLine xmlns="" xmlns:a14="http://schemas.microsoft.com/office/drawing/2010/main" w="9525">
+                  <a14:hiddenLine xmlns:a14="http://schemas.microsoft.com/office/drawing/2010/main" xmlns="" w="9525">
                     <a:solidFill>
                       <a:srgbClr val="000000"/>
                     </a:solidFill>
@@ -11589,7 +11589,7 @@
               </a:ln>
               <a:extLst>
                 <a:ext uri="{91240B29-F687-4f45-9708-019B960494DF}">
-                  <a14:hiddenLine xmlns="" xmlns:a14="http://schemas.microsoft.com/office/drawing/2010/main" w="9525">
+                  <a14:hiddenLine xmlns:a14="http://schemas.microsoft.com/office/drawing/2010/main" xmlns="" w="9525">
                     <a:solidFill>
                       <a:srgbClr val="000000"/>
                     </a:solidFill>
@@ -11658,7 +11658,7 @@
               </a:ln>
               <a:extLst>
                 <a:ext uri="{91240B29-F687-4f45-9708-019B960494DF}">
-                  <a14:hiddenLine xmlns="" xmlns:a14="http://schemas.microsoft.com/office/drawing/2010/main" w="9525">
+                  <a14:hiddenLine xmlns:a14="http://schemas.microsoft.com/office/drawing/2010/main" xmlns="" w="9525">
                     <a:solidFill>
                       <a:srgbClr val="000000"/>
                     </a:solidFill>
@@ -11727,7 +11727,7 @@
               </a:ln>
               <a:extLst>
                 <a:ext uri="{91240B29-F687-4f45-9708-019B960494DF}">
-                  <a14:hiddenLine xmlns="" xmlns:a14="http://schemas.microsoft.com/office/drawing/2010/main" w="9525">
+                  <a14:hiddenLine xmlns:a14="http://schemas.microsoft.com/office/drawing/2010/main" xmlns="" w="9525">
                     <a:solidFill>
                       <a:srgbClr val="000000"/>
                     </a:solidFill>
@@ -11824,7 +11824,7 @@
               </a:ln>
               <a:extLst>
                 <a:ext uri="{91240B29-F687-4f45-9708-019B960494DF}">
-                  <a14:hiddenLine xmlns="" xmlns:a14="http://schemas.microsoft.com/office/drawing/2010/main" w="9525">
+                  <a14:hiddenLine xmlns:a14="http://schemas.microsoft.com/office/drawing/2010/main" xmlns="" w="9525">
                     <a:solidFill>
                       <a:srgbClr val="000000"/>
                     </a:solidFill>
@@ -11865,7 +11865,7 @@
               </a:ln>
               <a:extLst>
                 <a:ext uri="{91240B29-F687-4f45-9708-019B960494DF}">
-                  <a14:hiddenLine xmlns="" xmlns:a14="http://schemas.microsoft.com/office/drawing/2010/main" w="9525">
+                  <a14:hiddenLine xmlns:a14="http://schemas.microsoft.com/office/drawing/2010/main" xmlns="" w="9525">
                     <a:solidFill>
                       <a:srgbClr val="000000"/>
                     </a:solidFill>
@@ -11937,7 +11937,7 @@
               </a:ln>
               <a:extLst>
                 <a:ext uri="{91240B29-F687-4f45-9708-019B960494DF}">
-                  <a14:hiddenLine xmlns="" xmlns:a14="http://schemas.microsoft.com/office/drawing/2010/main" w="9525">
+                  <a14:hiddenLine xmlns:a14="http://schemas.microsoft.com/office/drawing/2010/main" xmlns="" w="9525">
                     <a:solidFill>
                       <a:srgbClr val="000000"/>
                     </a:solidFill>
@@ -12034,7 +12034,7 @@
               </a:ln>
               <a:extLst>
                 <a:ext uri="{91240B29-F687-4f45-9708-019B960494DF}">
-                  <a14:hiddenLine xmlns="" xmlns:a14="http://schemas.microsoft.com/office/drawing/2010/main" w="9525">
+                  <a14:hiddenLine xmlns:a14="http://schemas.microsoft.com/office/drawing/2010/main" xmlns="" w="9525">
                     <a:solidFill>
                       <a:srgbClr val="000000"/>
                     </a:solidFill>
@@ -12103,7 +12103,7 @@
               </a:ln>
               <a:extLst>
                 <a:ext uri="{91240B29-F687-4f45-9708-019B960494DF}">
-                  <a14:hiddenLine xmlns="" xmlns:a14="http://schemas.microsoft.com/office/drawing/2010/main" w="9525">
+                  <a14:hiddenLine xmlns:a14="http://schemas.microsoft.com/office/drawing/2010/main" xmlns="" w="9525">
                     <a:solidFill>
                       <a:srgbClr val="000000"/>
                     </a:solidFill>
@@ -12200,7 +12200,7 @@
               </a:ln>
               <a:extLst>
                 <a:ext uri="{91240B29-F687-4f45-9708-019B960494DF}">
-                  <a14:hiddenLine xmlns="" xmlns:a14="http://schemas.microsoft.com/office/drawing/2010/main" w="9525">
+                  <a14:hiddenLine xmlns:a14="http://schemas.microsoft.com/office/drawing/2010/main" xmlns="" w="9525">
                     <a:solidFill>
                       <a:srgbClr val="000000"/>
                     </a:solidFill>
@@ -12272,7 +12272,7 @@
               </a:ln>
               <a:extLst>
                 <a:ext uri="{91240B29-F687-4f45-9708-019B960494DF}">
-                  <a14:hiddenLine xmlns="" xmlns:a14="http://schemas.microsoft.com/office/drawing/2010/main" w="9525">
+                  <a14:hiddenLine xmlns:a14="http://schemas.microsoft.com/office/drawing/2010/main" xmlns="" w="9525">
                     <a:solidFill>
                       <a:srgbClr val="000000"/>
                     </a:solidFill>
@@ -12341,7 +12341,7 @@
               </a:ln>
               <a:extLst>
                 <a:ext uri="{91240B29-F687-4f45-9708-019B960494DF}">
-                  <a14:hiddenLine xmlns="" xmlns:a14="http://schemas.microsoft.com/office/drawing/2010/main" w="9525">
+                  <a14:hiddenLine xmlns:a14="http://schemas.microsoft.com/office/drawing/2010/main" xmlns="" w="9525">
                     <a:solidFill>
                       <a:srgbClr val="000000"/>
                     </a:solidFill>
@@ -12438,7 +12438,7 @@
               </a:ln>
               <a:extLst>
                 <a:ext uri="{91240B29-F687-4f45-9708-019B960494DF}">
-                  <a14:hiddenLine xmlns="" xmlns:a14="http://schemas.microsoft.com/office/drawing/2010/main" w="9525">
+                  <a14:hiddenLine xmlns:a14="http://schemas.microsoft.com/office/drawing/2010/main" xmlns="" w="9525">
                     <a:solidFill>
                       <a:srgbClr val="000000"/>
                     </a:solidFill>
@@ -12535,7 +12535,7 @@
               </a:ln>
               <a:extLst>
                 <a:ext uri="{91240B29-F687-4f45-9708-019B960494DF}">
-                  <a14:hiddenLine xmlns="" xmlns:a14="http://schemas.microsoft.com/office/drawing/2010/main" w="9525">
+                  <a14:hiddenLine xmlns:a14="http://schemas.microsoft.com/office/drawing/2010/main" xmlns="" w="9525">
                     <a:solidFill>
                       <a:srgbClr val="000000"/>
                     </a:solidFill>
@@ -12607,7 +12607,7 @@
               </a:ln>
               <a:extLst>
                 <a:ext uri="{91240B29-F687-4f45-9708-019B960494DF}">
-                  <a14:hiddenLine xmlns="" xmlns:a14="http://schemas.microsoft.com/office/drawing/2010/main" w="9525">
+                  <a14:hiddenLine xmlns:a14="http://schemas.microsoft.com/office/drawing/2010/main" xmlns="" w="9525">
                     <a:solidFill>
                       <a:srgbClr val="000000"/>
                     </a:solidFill>
@@ -12734,7 +12734,7 @@
               </a:ln>
               <a:extLst>
                 <a:ext uri="{91240B29-F687-4f45-9708-019B960494DF}">
-                  <a14:hiddenLine xmlns="" xmlns:a14="http://schemas.microsoft.com/office/drawing/2010/main" w="9525">
+                  <a14:hiddenLine xmlns:a14="http://schemas.microsoft.com/office/drawing/2010/main" xmlns="" w="9525">
                     <a:solidFill>
                       <a:srgbClr val="000000"/>
                     </a:solidFill>
@@ -12822,7 +12822,7 @@
               </a:ln>
               <a:extLst>
                 <a:ext uri="{91240B29-F687-4f45-9708-019B960494DF}">
-                  <a14:hiddenLine xmlns="" xmlns:a14="http://schemas.microsoft.com/office/drawing/2010/main" w="9525">
+                  <a14:hiddenLine xmlns:a14="http://schemas.microsoft.com/office/drawing/2010/main" xmlns="" w="9525">
                     <a:solidFill>
                       <a:srgbClr val="000000"/>
                     </a:solidFill>
@@ -12944,7 +12944,7 @@
               </a:ln>
               <a:extLst>
                 <a:ext uri="{91240B29-F687-4f45-9708-019B960494DF}">
-                  <a14:hiddenLine xmlns="" xmlns:a14="http://schemas.microsoft.com/office/drawing/2010/main" w="9525">
+                  <a14:hiddenLine xmlns:a14="http://schemas.microsoft.com/office/drawing/2010/main" xmlns="" w="9525">
                     <a:solidFill>
                       <a:srgbClr val="000000"/>
                     </a:solidFill>
@@ -13041,7 +13041,7 @@
               </a:ln>
               <a:extLst>
                 <a:ext uri="{91240B29-F687-4f45-9708-019B960494DF}">
-                  <a14:hiddenLine xmlns="" xmlns:a14="http://schemas.microsoft.com/office/drawing/2010/main" w="9525">
+                  <a14:hiddenLine xmlns:a14="http://schemas.microsoft.com/office/drawing/2010/main" xmlns="" w="9525">
                     <a:solidFill>
                       <a:srgbClr val="000000"/>
                     </a:solidFill>
@@ -13113,7 +13113,7 @@
               </a:ln>
               <a:extLst>
                 <a:ext uri="{91240B29-F687-4f45-9708-019B960494DF}">
-                  <a14:hiddenLine xmlns="" xmlns:a14="http://schemas.microsoft.com/office/drawing/2010/main" w="9525">
+                  <a14:hiddenLine xmlns:a14="http://schemas.microsoft.com/office/drawing/2010/main" xmlns="" w="9525">
                     <a:solidFill>
                       <a:srgbClr val="000000"/>
                     </a:solidFill>
@@ -13210,7 +13210,7 @@
               </a:ln>
               <a:extLst>
                 <a:ext uri="{91240B29-F687-4f45-9708-019B960494DF}">
-                  <a14:hiddenLine xmlns="" xmlns:a14="http://schemas.microsoft.com/office/drawing/2010/main" w="9525">
+                  <a14:hiddenLine xmlns:a14="http://schemas.microsoft.com/office/drawing/2010/main" xmlns="" w="9525">
                     <a:solidFill>
                       <a:srgbClr val="000000"/>
                     </a:solidFill>
@@ -13285,7 +13285,7 @@
               </a:ln>
               <a:extLst>
                 <a:ext uri="{91240B29-F687-4f45-9708-019B960494DF}">
-                  <a14:hiddenLine xmlns="" xmlns:a14="http://schemas.microsoft.com/office/drawing/2010/main" w="9525">
+                  <a14:hiddenLine xmlns:a14="http://schemas.microsoft.com/office/drawing/2010/main" xmlns="" w="9525">
                     <a:solidFill>
                       <a:srgbClr val="000000"/>
                     </a:solidFill>
@@ -13382,7 +13382,7 @@
               </a:ln>
               <a:extLst>
                 <a:ext uri="{91240B29-F687-4f45-9708-019B960494DF}">
-                  <a14:hiddenLine xmlns="" xmlns:a14="http://schemas.microsoft.com/office/drawing/2010/main" w="9525">
+                  <a14:hiddenLine xmlns:a14="http://schemas.microsoft.com/office/drawing/2010/main" xmlns="" w="9525">
                     <a:solidFill>
                       <a:srgbClr val="000000"/>
                     </a:solidFill>
@@ -13457,7 +13457,7 @@
               </a:ln>
               <a:extLst>
                 <a:ext uri="{91240B29-F687-4f45-9708-019B960494DF}">
-                  <a14:hiddenLine xmlns="" xmlns:a14="http://schemas.microsoft.com/office/drawing/2010/main" w="9525">
+                  <a14:hiddenLine xmlns:a14="http://schemas.microsoft.com/office/drawing/2010/main" xmlns="" w="9525">
                     <a:solidFill>
                       <a:srgbClr val="000000"/>
                     </a:solidFill>
@@ -13554,7 +13554,7 @@
               </a:ln>
               <a:extLst>
                 <a:ext uri="{91240B29-F687-4f45-9708-019B960494DF}">
-                  <a14:hiddenLine xmlns="" xmlns:a14="http://schemas.microsoft.com/office/drawing/2010/main" w="9525">
+                  <a14:hiddenLine xmlns:a14="http://schemas.microsoft.com/office/drawing/2010/main" xmlns="" w="9525">
                     <a:solidFill>
                       <a:srgbClr val="000000"/>
                     </a:solidFill>
@@ -13595,7 +13595,7 @@
               </a:ln>
               <a:extLst>
                 <a:ext uri="{91240B29-F687-4f45-9708-019B960494DF}">
-                  <a14:hiddenLine xmlns="" xmlns:a14="http://schemas.microsoft.com/office/drawing/2010/main" w="9525">
+                  <a14:hiddenLine xmlns:a14="http://schemas.microsoft.com/office/drawing/2010/main" xmlns="" w="9525">
                     <a:solidFill>
                       <a:srgbClr val="000000"/>
                     </a:solidFill>
@@ -15847,6 +15847,12 @@
             <a:r>
               <a:rPr lang="de-DE" sz="2000" dirty="0"/>
               <a:t>Mangelnde Genauigkeit in den Prompts hat zu Ineffizientes geführt</a:t>
+            </a:r>
+          </a:p>
+          <a:p>
+            <a:r>
+              <a:rPr lang="de-DE" sz="2000" dirty="0"/>
+              <a:t>Bei ausführlichen Prompts wurden die aufgaben gut erledigt</a:t>
             </a:r>
           </a:p>
         </p:txBody>

</xml_diff>